<commit_message>
chore: update live Vercel deployment URL across PPT and PDF
</commit_message>
<xml_diff>
--- a/SIH26262_AICTE_Winning_Presentation.pptx
+++ b/SIH26262_AICTE_Winning_Presentation.pptx
@@ -7295,7 +7295,7 @@
                   <a:srgbClr val="93C5FD"/>
                 </a:solidFill>
               </a:rPr>
-              <a:t>https://pravaah-aicte.vercel.app</a:t>
+              <a:t>https://frontend-lyart-chi-21.vercel.app</a:t>
             </a:r>
           </a:p>
           <a:p>
@@ -7313,7 +7313,7 @@
                   <a:srgbClr val="93C5FD"/>
                 </a:solidFill>
               </a:rPr>
-              <a:t>https://github.com/team-pravaah360/aicte-approval-workflow.git</a:t>
+              <a:t>https://github.com/divyanshattrish/pravaah360-aicte.git</a:t>
             </a:r>
           </a:p>
           <a:p>

</xml_diff>